<commit_message>
teste e melhoria no slide
</commit_message>
<xml_diff>
--- a/docs/Presentation.pptx
+++ b/docs/Presentation.pptx
@@ -3558,56 +3558,62 @@
           </a:p>
         </p:txBody>
       </p:sp>
-      <p:sp>
-        <p:nvSpPr>
-          <p:cNvPr id="3" name="Espaço Reservado para Conteúdo 2">
+      <p:pic>
+        <p:nvPicPr>
+          <p:cNvPr id="8" name="Espaço Reservado para Conteúdo 7">
             <a:extLst>
               <a:ext uri="{FF2B5EF4-FFF2-40B4-BE49-F238E27FC236}">
-                <a16:creationId xmlns:a16="http://schemas.microsoft.com/office/drawing/2014/main" id="{030DAACF-01D1-4939-B40A-B7540663CB0E}"/>
+                <a16:creationId xmlns:a16="http://schemas.microsoft.com/office/drawing/2014/main" id="{8F16DFB2-54D4-464C-B593-DC95E975326F}"/>
               </a:ext>
             </a:extLst>
           </p:cNvPr>
-          <p:cNvSpPr>
-            <a:spLocks noGrp="1"/>
-          </p:cNvSpPr>
+          <p:cNvPicPr>
+            <a:picLocks noGrp="1" noChangeAspect="1"/>
+          </p:cNvPicPr>
           <p:nvPr>
             <p:ph idx="1"/>
           </p:nvPr>
-        </p:nvSpPr>
-        <p:spPr/>
-        <p:txBody>
-          <a:bodyPr>
-            <a:normAutofit/>
-          </a:bodyPr>
-          <a:lstStyle/>
-          <a:p>
-            <a:r>
-              <a:rPr lang="pt-BR" dirty="0"/>
-              <a:t>Pesquisa de documentos oficiais e tabelas nas páginas das bandeiras (Visa e Mastercard).</a:t>
-            </a:r>
-          </a:p>
-          <a:p>
-            <a:r>
-              <a:rPr lang="pt-BR" dirty="0"/>
-              <a:t>Extração manual e via OCR dos dados em </a:t>
-            </a:r>
-            <a:r>
-              <a:rPr lang="pt-BR" dirty="0" err="1"/>
-              <a:t>PDFs</a:t>
-            </a:r>
-            <a:r>
-              <a:rPr lang="pt-BR" dirty="0"/>
-              <a:t> e imagens (tabelas em PNG no site da Mastercard).</a:t>
-            </a:r>
-          </a:p>
-          <a:p>
-            <a:r>
-              <a:rPr lang="pt-BR" dirty="0"/>
-              <a:t>Estruturação dos dados em planilhas: identificação de categorias (tipo de cartão, segmento, ajustes).</a:t>
-            </a:r>
-          </a:p>
-        </p:txBody>
-      </p:sp>
+        </p:nvPicPr>
+        <p:blipFill>
+          <a:blip r:embed="rId2"/>
+          <a:stretch>
+            <a:fillRect/>
+          </a:stretch>
+        </p:blipFill>
+        <p:spPr>
+          <a:xfrm>
+            <a:off x="558964" y="1232647"/>
+            <a:ext cx="8026072" cy="5350715"/>
+          </a:xfrm>
+          <a:prstGeom prst="roundRect">
+            <a:avLst>
+              <a:gd name="adj" fmla="val 16667"/>
+            </a:avLst>
+          </a:prstGeom>
+          <a:ln>
+            <a:noFill/>
+          </a:ln>
+          <a:effectLst>
+            <a:outerShdw blurRad="76200" dist="38100" dir="7800000" algn="tl" rotWithShape="0">
+              <a:srgbClr val="000000">
+                <a:alpha val="40000"/>
+              </a:srgbClr>
+            </a:outerShdw>
+          </a:effectLst>
+          <a:scene3d>
+            <a:camera prst="orthographicFront"/>
+            <a:lightRig rig="contrasting" dir="t">
+              <a:rot lat="0" lon="0" rev="4200000"/>
+            </a:lightRig>
+          </a:scene3d>
+          <a:sp3d prstMaterial="plastic">
+            <a:bevelT w="381000" h="114300" prst="relaxedInset"/>
+            <a:contourClr>
+              <a:srgbClr val="969696"/>
+            </a:contourClr>
+          </a:sp3d>
+        </p:spPr>
+      </p:pic>
     </p:spTree>
   </p:cSld>
   <p:clrMapOvr>
@@ -3695,7 +3701,15 @@
           <a:p>
             <a:r>
               <a:rPr lang="pt-BR" dirty="0"/>
-              <a:t>Mas os dados analisados são majoritariamente amostras textuais extraídos no portal de cada instituição.</a:t>
+              <a:t>Mas os dados </a:t>
+            </a:r>
+            <a:r>
+              <a:rPr lang="pt-BR"/>
+              <a:t>analisados são majoritariamente </a:t>
+            </a:r>
+            <a:r>
+              <a:rPr lang="pt-BR" dirty="0"/>
+              <a:t>amostras textuais extraídos no portal de cada instituição.</a:t>
             </a:r>
             <a:endParaRPr lang="pt-BR" b="1" dirty="0"/>
           </a:p>

</xml_diff>